<commit_message>
Rebrand store to Northlane with Arman founder contact.
Co-authored-by: Cursor <cursoragent@cursor.com>
</commit_message>
<xml_diff>
--- a/COMP101_Project1/Presentation/COMP101_Project1_Presentation.pptx
+++ b/COMP101_Project1/Presentation/COMP101_Project1_Presentation.pptx
@@ -1622,7 +1622,7 @@
                 <a:ea typeface="Calibri" pitchFamily="34" charset="-122"/>
                 <a:cs typeface="Calibri" pitchFamily="34" charset="-120"/>
               </a:rPr>
-              <a:t>Peakline Outfitters</a:t>
+              <a:t>Northlane Outfitters</a:t>
             </a:r>
             <a:endParaRPr lang="en-US" sz="2200" dirty="0"/>
           </a:p>
@@ -1661,7 +1661,7 @@
                 <a:ea typeface="Calibri" pitchFamily="34" charset="-122"/>
                 <a:cs typeface="Calibri" pitchFamily="34" charset="-120"/>
               </a:rPr>
-              <a:t>Alex Morgan</a:t>
+              <a:t>Mohammad Arman</a:t>
             </a:r>
             <a:endParaRPr lang="en-US" sz="1800" dirty="0"/>
           </a:p>
@@ -1678,7 +1678,7 @@
                 <a:ea typeface="Calibri" pitchFamily="34" charset="-122"/>
                 <a:cs typeface="Calibri" pitchFamily="34" charset="-120"/>
               </a:rPr>
-              <a:t>Sam Rivera</a:t>
+              <a:t>Mohammad Arman</a:t>
             </a:r>
             <a:endParaRPr lang="en-US" sz="1800" dirty="0"/>
           </a:p>
@@ -1801,7 +1801,7 @@
                 <a:ea typeface="Georgia" pitchFamily="34" charset="-122"/>
                 <a:cs typeface="Georgia" pitchFamily="34" charset="-120"/>
               </a:rPr>
-              <a:t>Peakline Outfitters</a:t>
+              <a:t>Northlane Outfitters</a:t>
             </a:r>
             <a:endParaRPr lang="en-US" sz="3200" dirty="0"/>
           </a:p>
@@ -1863,7 +1863,7 @@
                 <a:ea typeface="Calibri" pitchFamily="34" charset="-122"/>
                 <a:cs typeface="Calibri" pitchFamily="34" charset="-120"/>
               </a:rPr>
-              <a:t>Platform: Peakline Commerce (Next.js e-commerce platform)</a:t>
+              <a:t>Platform: Northlane Commerce (Next.js e-commerce platform)</a:t>
             </a:r>
             <a:endParaRPr lang="en-US" sz="1800" dirty="0"/>
           </a:p>
@@ -1914,7 +1914,24 @@
                 <a:ea typeface="Calibri" pitchFamily="34" charset="-122"/>
                 <a:cs typeface="Calibri" pitchFamily="34" charset="-120"/>
               </a:rPr>
-              <a:t>Login: admin / Peakline101</a:t>
+              <a:t>Login: admin / Northlane101</a:t>
+            </a:r>
+            <a:endParaRPr lang="en-US" sz="1800" dirty="0"/>
+          </a:p>
+          <a:p>
+            <a:pPr indent="0" marL="0">
+              <a:buNone/>
+            </a:pPr>
+            <a:r>
+              <a:rPr lang="en-US" sz="1800" dirty="0">
+                <a:solidFill>
+                  <a:srgbClr val="F4F0E8"/>
+                </a:solidFill>
+                <a:latin typeface="Calibri" pitchFamily="34" charset="0"/>
+                <a:ea typeface="Calibri" pitchFamily="34" charset="-122"/>
+                <a:cs typeface="Calibri" pitchFamily="34" charset="-120"/>
+              </a:rPr>
+              <a:t>Founder: Mohammad Arman</a:t>
             </a:r>
             <a:endParaRPr lang="en-US" sz="1800" dirty="0"/>
           </a:p>
@@ -2518,7 +2535,7 @@
                           <a:ea typeface="Calibri" pitchFamily="34" charset="-122"/>
                           <a:cs typeface="Calibri" pitchFamily="34" charset="-120"/>
                         </a:rPr>
-                        <a:t>PL-HIK-001</a:t>
+                        <a:t>NL-HIK-001</a:t>
                       </a:r>
                       <a:endParaRPr lang="en-US" sz="1100" dirty="0">
                         <a:latin typeface="Calibri" charset="0"/>
@@ -2928,7 +2945,7 @@
                           <a:ea typeface="Calibri" pitchFamily="34" charset="-122"/>
                           <a:cs typeface="Calibri" pitchFamily="34" charset="-120"/>
                         </a:rPr>
-                        <a:t>PL-HIK-002</a:t>
+                        <a:t>NL-HIK-002</a:t>
                       </a:r>
                       <a:endParaRPr lang="en-US" sz="1100" dirty="0">
                         <a:latin typeface="Calibri" charset="0"/>
@@ -3338,7 +3355,7 @@
                           <a:ea typeface="Calibri" pitchFamily="34" charset="-122"/>
                           <a:cs typeface="Calibri" pitchFamily="34" charset="-120"/>
                         </a:rPr>
-                        <a:t>PL-HIK-003</a:t>
+                        <a:t>NL-HIK-003</a:t>
                       </a:r>
                       <a:endParaRPr lang="en-US" sz="1100" dirty="0">
                         <a:latin typeface="Calibri" charset="0"/>
@@ -3748,7 +3765,7 @@
                           <a:ea typeface="Calibri" pitchFamily="34" charset="-122"/>
                           <a:cs typeface="Calibri" pitchFamily="34" charset="-120"/>
                         </a:rPr>
-                        <a:t>PL-HIK-004</a:t>
+                        <a:t>NL-HIK-004</a:t>
                       </a:r>
                       <a:endParaRPr lang="en-US" sz="1100" dirty="0">
                         <a:latin typeface="Calibri" charset="0"/>
@@ -4158,7 +4175,7 @@
                           <a:ea typeface="Calibri" pitchFamily="34" charset="-122"/>
                           <a:cs typeface="Calibri" pitchFamily="34" charset="-120"/>
                         </a:rPr>
-                        <a:t>PL-CMP-001</a:t>
+                        <a:t>NL-CMP-001</a:t>
                       </a:r>
                       <a:endParaRPr lang="en-US" sz="1100" dirty="0">
                         <a:latin typeface="Calibri" charset="0"/>
@@ -4568,7 +4585,7 @@
                           <a:ea typeface="Calibri" pitchFamily="34" charset="-122"/>
                           <a:cs typeface="Calibri" pitchFamily="34" charset="-120"/>
                         </a:rPr>
-                        <a:t>PL-CMP-002</a:t>
+                        <a:t>NL-CMP-002</a:t>
                       </a:r>
                       <a:endParaRPr lang="en-US" sz="1100" dirty="0">
                         <a:latin typeface="Calibri" charset="0"/>
@@ -4978,7 +4995,7 @@
                           <a:ea typeface="Calibri" pitchFamily="34" charset="-122"/>
                           <a:cs typeface="Calibri" pitchFamily="34" charset="-120"/>
                         </a:rPr>
-                        <a:t>PL-CMP-003</a:t>
+                        <a:t>NL-CMP-003</a:t>
                       </a:r>
                       <a:endParaRPr lang="en-US" sz="1100" dirty="0">
                         <a:latin typeface="Calibri" charset="0"/>
@@ -5388,7 +5405,7 @@
                           <a:ea typeface="Calibri" pitchFamily="34" charset="-122"/>
                           <a:cs typeface="Calibri" pitchFamily="34" charset="-120"/>
                         </a:rPr>
-                        <a:t>PL-CMP-004</a:t>
+                        <a:t>NL-CMP-004</a:t>
                       </a:r>
                       <a:endParaRPr lang="en-US" sz="1100" dirty="0">
                         <a:latin typeface="Calibri" charset="0"/>
@@ -5798,7 +5815,7 @@
                           <a:ea typeface="Calibri" pitchFamily="34" charset="-122"/>
                           <a:cs typeface="Calibri" pitchFamily="34" charset="-120"/>
                         </a:rPr>
-                        <a:t>PL-TRV-001</a:t>
+                        <a:t>NL-TRV-001</a:t>
                       </a:r>
                       <a:endParaRPr lang="en-US" sz="1100" dirty="0">
                         <a:latin typeface="Calibri" charset="0"/>
@@ -6208,7 +6225,7 @@
                           <a:ea typeface="Calibri" pitchFamily="34" charset="-122"/>
                           <a:cs typeface="Calibri" pitchFamily="34" charset="-120"/>
                         </a:rPr>
-                        <a:t>PL-TRV-002</a:t>
+                        <a:t>NL-TRV-002</a:t>
                       </a:r>
                       <a:endParaRPr lang="en-US" sz="1100" dirty="0">
                         <a:latin typeface="Calibri" charset="0"/>
@@ -7779,7 +7796,7 @@
                           <a:ea typeface="Calibri" pitchFamily="34" charset="-122"/>
                           <a:cs typeface="Calibri" pitchFamily="34" charset="-120"/>
                         </a:rPr>
-                        <a:t>PL-HIK-001</a:t>
+                        <a:t>NL-HIK-001</a:t>
                       </a:r>
                       <a:endParaRPr lang="en-US" sz="1200" dirty="0">
                         <a:latin typeface="Calibri" charset="0"/>
@@ -7913,7 +7930,7 @@
                           <a:ea typeface="Calibri" pitchFamily="34" charset="-122"/>
                           <a:cs typeface="Calibri" pitchFamily="34" charset="-120"/>
                         </a:rPr>
-                        <a:t>PL-HIK-002</a:t>
+                        <a:t>NL-HIK-002</a:t>
                       </a:r>
                       <a:endParaRPr lang="en-US" sz="1200" dirty="0">
                         <a:latin typeface="Calibri" charset="0"/>
@@ -8047,7 +8064,7 @@
                           <a:ea typeface="Calibri" pitchFamily="34" charset="-122"/>
                           <a:cs typeface="Calibri" pitchFamily="34" charset="-120"/>
                         </a:rPr>
-                        <a:t>PL-HIK-003</a:t>
+                        <a:t>NL-HIK-003</a:t>
                       </a:r>
                       <a:endParaRPr lang="en-US" sz="1200" dirty="0">
                         <a:latin typeface="Calibri" charset="0"/>
@@ -8181,7 +8198,7 @@
                           <a:ea typeface="Calibri" pitchFamily="34" charset="-122"/>
                           <a:cs typeface="Calibri" pitchFamily="34" charset="-120"/>
                         </a:rPr>
-                        <a:t>PL-HIK-004</a:t>
+                        <a:t>NL-HIK-004</a:t>
                       </a:r>
                       <a:endParaRPr lang="en-US" sz="1200" dirty="0">
                         <a:latin typeface="Calibri" charset="0"/>
@@ -8315,7 +8332,7 @@
                           <a:ea typeface="Calibri" pitchFamily="34" charset="-122"/>
                           <a:cs typeface="Calibri" pitchFamily="34" charset="-120"/>
                         </a:rPr>
-                        <a:t>PL-CMP-001</a:t>
+                        <a:t>NL-CMP-001</a:t>
                       </a:r>
                       <a:endParaRPr lang="en-US" sz="1200" dirty="0">
                         <a:latin typeface="Calibri" charset="0"/>
@@ -8449,7 +8466,7 @@
                           <a:ea typeface="Calibri" pitchFamily="34" charset="-122"/>
                           <a:cs typeface="Calibri" pitchFamily="34" charset="-120"/>
                         </a:rPr>
-                        <a:t>PL-CMP-002</a:t>
+                        <a:t>NL-CMP-002</a:t>
                       </a:r>
                       <a:endParaRPr lang="en-US" sz="1200" dirty="0">
                         <a:latin typeface="Calibri" charset="0"/>
@@ -8583,7 +8600,7 @@
                           <a:ea typeface="Calibri" pitchFamily="34" charset="-122"/>
                           <a:cs typeface="Calibri" pitchFamily="34" charset="-120"/>
                         </a:rPr>
-                        <a:t>PL-CMP-003</a:t>
+                        <a:t>NL-CMP-003</a:t>
                       </a:r>
                       <a:endParaRPr lang="en-US" sz="1200" dirty="0">
                         <a:latin typeface="Calibri" charset="0"/>
@@ -8717,7 +8734,7 @@
                           <a:ea typeface="Calibri" pitchFamily="34" charset="-122"/>
                           <a:cs typeface="Calibri" pitchFamily="34" charset="-120"/>
                         </a:rPr>
-                        <a:t>PL-CMP-004</a:t>
+                        <a:t>NL-CMP-004</a:t>
                       </a:r>
                       <a:endParaRPr lang="en-US" sz="1200" dirty="0">
                         <a:latin typeface="Calibri" charset="0"/>
@@ -8851,7 +8868,7 @@
                           <a:ea typeface="Calibri" pitchFamily="34" charset="-122"/>
                           <a:cs typeface="Calibri" pitchFamily="34" charset="-120"/>
                         </a:rPr>
-                        <a:t>PL-TRV-001</a:t>
+                        <a:t>NL-TRV-001</a:t>
                       </a:r>
                       <a:endParaRPr lang="en-US" sz="1200" dirty="0">
                         <a:latin typeface="Calibri" charset="0"/>
@@ -8985,7 +9002,7 @@
                           <a:ea typeface="Calibri" pitchFamily="34" charset="-122"/>
                           <a:cs typeface="Calibri" pitchFamily="34" charset="-120"/>
                         </a:rPr>
-                        <a:t>PL-TRV-002</a:t>
+                        <a:t>NL-TRV-002</a:t>
                       </a:r>
                       <a:endParaRPr lang="en-US" sz="1200" dirty="0">
                         <a:latin typeface="Calibri" charset="0"/>
@@ -9352,7 +9369,7 @@
                 <a:ea typeface="Calibri" pitchFamily="34" charset="-122"/>
                 <a:cs typeface="Calibri" pitchFamily="34" charset="-120"/>
               </a:rPr>
-              <a:t>SKU: PL-TRV-002</a:t>
+              <a:t>SKU: NL-TRV-002</a:t>
             </a:r>
             <a:endParaRPr lang="en-US" sz="2000" dirty="0"/>
           </a:p>
@@ -9475,7 +9492,7 @@
                 <a:ea typeface="Georgia" pitchFamily="34" charset="-122"/>
                 <a:cs typeface="Georgia" pitchFamily="34" charset="-120"/>
               </a:rPr>
-              <a:t>Test order PKL-10001</a:t>
+              <a:t>Test order NL-10001</a:t>
             </a:r>
             <a:endParaRPr lang="en-US" sz="3200" dirty="0"/>
           </a:p>

</xml_diff>

<commit_message>
Show one student name and complete order details pages.
Co-authored-by: Cursor <cursoragent@cursor.com>
</commit_message>
<xml_diff>
--- a/COMP101_Project1/Presentation/COMP101_Project1_Presentation.pptx
+++ b/COMP101_Project1/Presentation/COMP101_Project1_Presentation.pptx
@@ -1637,7 +1637,7 @@
         <p:spPr>
           <a:xfrm>
             <a:off x="640080" y="4023360"/>
-            <a:ext cx="10972800" cy="914400"/>
+            <a:ext cx="10972800" cy="548640"/>
           </a:xfrm>
           <a:prstGeom prst="rect">
             <a:avLst/>
@@ -1661,24 +1661,7 @@
                 <a:ea typeface="Calibri" pitchFamily="34" charset="-122"/>
                 <a:cs typeface="Calibri" pitchFamily="34" charset="-120"/>
               </a:rPr>
-              <a:t>Mohammad Arman</a:t>
-            </a:r>
-            <a:endParaRPr lang="en-US" sz="1800" dirty="0"/>
-          </a:p>
-          <a:p>
-            <a:pPr indent="0" marL="0">
-              <a:buNone/>
-            </a:pPr>
-            <a:r>
-              <a:rPr lang="en-US" sz="1800" dirty="0">
-                <a:solidFill>
-                  <a:srgbClr val="F4F0E8"/>
-                </a:solidFill>
-                <a:latin typeface="Calibri" pitchFamily="34" charset="0"/>
-                <a:ea typeface="Calibri" pitchFamily="34" charset="-122"/>
-                <a:cs typeface="Calibri" pitchFamily="34" charset="-120"/>
-              </a:rPr>
-              <a:t>Mohammad Arman</a:t>
+              <a:t>Student Full Name: Mohammad Arman</a:t>
             </a:r>
             <a:endParaRPr lang="en-US" sz="1800" dirty="0"/>
           </a:p>

</xml_diff>